<commit_message>
Q1 Week01 submission: report and presentation
</commit_message>
<xml_diff>
--- a/matome/中間発表修正.pptx
+++ b/matome/中間発表修正.pptx
@@ -4467,8 +4467,10 @@
               </a:defRPr>
             </a:pPr>
             <a:r>
+              <a:rPr dirty="0" err="1"/>
               <a:t>座標処理の整理</a:t>
             </a:r>
+            <a:endParaRPr dirty="0"/>
           </a:p>
           <a:p>
             <a:pPr>
@@ -4482,8 +4484,10 @@
               </a:defRPr>
             </a:pPr>
             <a:r>
+              <a:rPr dirty="0" err="1"/>
               <a:t>画像平面上の座標へ変換</a:t>
             </a:r>
+            <a:endParaRPr dirty="0"/>
           </a:p>
         </p:txBody>
       </p:sp>
@@ -4635,6 +4639,7 @@
               </a:defRPr>
             </a:pPr>
             <a:r>
+              <a:rPr dirty="0"/>
               <a:t>3点の設定化</a:t>
             </a:r>
           </a:p>
@@ -4650,8 +4655,18 @@
               </a:defRPr>
             </a:pPr>
             <a:r>
-              <a:t>角度計算に使う関節を設定から取得</a:t>
-            </a:r>
+              <a:rPr dirty="0" err="1"/>
+              <a:t>角度計算に使う関節を設定</a:t>
+            </a:r>
+            <a:r>
+              <a:rPr lang="ja-JP" altLang="en-US" dirty="0"/>
+              <a:t>ファイル</a:t>
+            </a:r>
+            <a:r>
+              <a:rPr dirty="0" err="1"/>
+              <a:t>から取得</a:t>
+            </a:r>
+            <a:endParaRPr dirty="0"/>
           </a:p>
         </p:txBody>
       </p:sp>
@@ -7102,8 +7117,10 @@
               </a:defRPr>
             </a:pPr>
             <a:r>
+              <a:rPr dirty="0" err="1"/>
               <a:t>種目数が増えるほど、修正・保守の負担が増える</a:t>
             </a:r>
+            <a:endParaRPr dirty="0"/>
           </a:p>
         </p:txBody>
       </p:sp>
@@ -7793,7 +7810,12 @@
               </a:defRPr>
             </a:pPr>
             <a:r>
-              <a:t>研究課題（RQ）</a:t>
+              <a:rPr dirty="0" err="1"/>
+              <a:t>研究課題（RQ</a:t>
+            </a:r>
+            <a:r>
+              <a:rPr dirty="0"/>
+              <a:t>）</a:t>
             </a:r>
           </a:p>
           <a:p>
@@ -7808,20 +7830,45 @@
               </a:defRPr>
             </a:pPr>
             <a:r>
-              <a:t>関節指定、目標角度、判定条件などを、</a:t>
-            </a:r>
-            <a:br/>
-            <a:r>
-              <a:t>どこまで設定データの変更だけで扱えるか。</a:t>
-            </a:r>
-            <a:br/>
-            <a:br/>
-            <a:r>
-              <a:t>さらに、設定だけでは扱えない規則について、</a:t>
-            </a:r>
-            <a:br/>
-            <a:r>
-              <a:t>共通コードの追加・変更や個別処理が必要となる境界を明らかにする。</a:t>
+              <a:rPr dirty="0" err="1"/>
+              <a:t>関節指定、目標角度、判定条件などを、どこまで設定データの変更だけで扱えるか</a:t>
+            </a:r>
+            <a:r>
+              <a:rPr dirty="0"/>
+              <a:t>。</a:t>
+            </a:r>
+            <a:br>
+              <a:rPr dirty="0"/>
+            </a:br>
+            <a:br>
+              <a:rPr dirty="0"/>
+            </a:br>
+            <a:r>
+              <a:rPr dirty="0" err="1"/>
+              <a:t>さらに、設定だけでは扱えない</a:t>
+            </a:r>
+            <a:r>
+              <a:rPr lang="ja-JP" altLang="en-US" dirty="0"/>
+              <a:t>範囲</a:t>
+            </a:r>
+            <a:r>
+              <a:rPr dirty="0" err="1"/>
+              <a:t>について</a:t>
+            </a:r>
+            <a:r>
+              <a:rPr dirty="0"/>
+              <a:t>、</a:t>
+            </a:r>
+            <a:br>
+              <a:rPr dirty="0"/>
+            </a:br>
+            <a:r>
+              <a:rPr dirty="0" err="1"/>
+              <a:t>共通コードの追加・変更や個別処理が必要となる境界を明らかにする</a:t>
+            </a:r>
+            <a:r>
+              <a:rPr dirty="0"/>
+              <a:t>。</a:t>
             </a:r>
           </a:p>
         </p:txBody>
@@ -9015,7 +9062,7 @@
         <p:spPr>
           <a:xfrm>
             <a:off x="1143000" y="5532120"/>
-            <a:ext cx="9784080" cy="457200"/>
+            <a:ext cx="9784080" cy="353943"/>
           </a:xfrm>
           <a:prstGeom prst="rect">
             <a:avLst/>
@@ -9036,7 +9083,20 @@
               </a:defRPr>
             </a:pPr>
             <a:r>
-              <a:t>狙い：種目固有の情報を設定として分離し、共通処理を再利用する。</a:t>
+              <a:rPr dirty="0" err="1"/>
+              <a:t>狙い：種目固有の情報を設定として分離し、共通処理を</a:t>
+            </a:r>
+            <a:r>
+              <a:rPr lang="ja-JP" altLang="en-US" dirty="0"/>
+              <a:t>複数の種目で利用</a:t>
+            </a:r>
+            <a:r>
+              <a:rPr dirty="0" err="1"/>
+              <a:t>する</a:t>
+            </a:r>
+            <a:r>
+              <a:rPr dirty="0"/>
+              <a:t>。</a:t>
             </a:r>
           </a:p>
         </p:txBody>
@@ -9642,7 +9702,7 @@
         <p:spPr>
           <a:xfrm>
             <a:off x="914400" y="5532120"/>
-            <a:ext cx="10332720" cy="502920"/>
+            <a:ext cx="10332720" cy="338554"/>
           </a:xfrm>
           <a:prstGeom prst="rect">
             <a:avLst/>
@@ -9664,7 +9724,11 @@
             </a:pPr>
             <a:r>
               <a:rPr dirty="0" err="1"/>
-              <a:t>ここが共通なら、種目固有の違いを設定側へ移せる可能性がある</a:t>
+              <a:t>ここが共通なら、種目固有の違いを設定</a:t>
+            </a:r>
+            <a:r>
+              <a:rPr lang="ja-JP" altLang="en-US" dirty="0"/>
+              <a:t>ファイルで指定できる</a:t>
             </a:r>
             <a:r>
               <a:rPr dirty="0"/>
@@ -12610,8 +12674,14 @@
               </a:defRPr>
             </a:pPr>
             <a:r>
-              <a:t>④ 変更量</a:t>
-            </a:r>
+              <a:rPr dirty="0"/>
+              <a:t>④ </a:t>
+            </a:r>
+            <a:r>
+              <a:rPr dirty="0" err="1"/>
+              <a:t>変更量</a:t>
+            </a:r>
+            <a:endParaRPr dirty="0"/>
           </a:p>
           <a:p>
             <a:pPr>
@@ -12625,12 +12695,29 @@
               </a:defRPr>
             </a:pPr>
             <a:r>
+              <a:rPr dirty="0" err="1"/>
               <a:t>種目追加時の変更箇所・コード量</a:t>
             </a:r>
-            <a:br/>
-            <a:r>
-              <a:t>→ 共通化の効果を記録</a:t>
-            </a:r>
+            <a:br>
+              <a:rPr dirty="0"/>
+            </a:br>
+            <a:r>
+              <a:rPr dirty="0"/>
+              <a:t>→ </a:t>
+            </a:r>
+            <a:r>
+              <a:rPr dirty="0" err="1"/>
+              <a:t>共通化</a:t>
+            </a:r>
+            <a:r>
+              <a:rPr lang="ja-JP" altLang="en-US" dirty="0"/>
+              <a:t>による変更量</a:t>
+            </a:r>
+            <a:r>
+              <a:rPr dirty="0" err="1"/>
+              <a:t>を記録</a:t>
+            </a:r>
+            <a:endParaRPr dirty="0"/>
           </a:p>
         </p:txBody>
       </p:sp>
@@ -12752,7 +12839,11 @@
             </a:r>
             <a:r>
               <a:rPr dirty="0" err="1"/>
-              <a:t>設定だけ</a:t>
+              <a:t>設定</a:t>
+            </a:r>
+            <a:r>
+              <a:rPr lang="ja-JP" altLang="en-US" dirty="0"/>
+              <a:t>ファイルのみ</a:t>
             </a:r>
             <a:r>
               <a:rPr dirty="0"/>
@@ -12760,7 +12851,15 @@
             </a:r>
             <a:r>
               <a:rPr dirty="0" err="1"/>
-              <a:t>共通コード変更</a:t>
+              <a:t>共通</a:t>
+            </a:r>
+            <a:r>
+              <a:rPr lang="ja-JP" altLang="en-US" dirty="0"/>
+              <a:t>処理の</a:t>
+            </a:r>
+            <a:r>
+              <a:rPr dirty="0" err="1"/>
+              <a:t>変更</a:t>
             </a:r>
             <a:r>
               <a:rPr dirty="0"/>

</xml_diff>